<commit_message>
Put the team on the title page
The brief registers the team through the deck and the CVs, so page 1 carries
both. Members are the four who appear in this repository's history plus Alex,
who has been reviewing rather than committing.

TEAM_NAME is left as a loud placeholder rather than blank or guessed. This
repository has no way to know it, and a visible "[TEAM NAME - FILL IN]" cannot
be shipped by accident the way an empty line can.

Co-Authored-By: Claude Opus 5 <noreply@anthropic.com>
</commit_message>
<xml_diff>
--- a/05_submission/FIAM_deck.pptx
+++ b/05_submission/FIAM_deck.pptx
@@ -2703,6 +2703,68 @@
           </a:p>
         </p:txBody>
       </p:sp>
+      <p:sp>
+        <p:nvSpPr>
+          <p:cNvPr id="22" name="Text 20"/>
+          <p:cNvSpPr txBox="1"/>
+          <p:nvPr/>
+        </p:nvSpPr>
+        <p:spPr>
+          <a:xfrm>
+            <a:off x="731520" y="6053328"/>
+            <a:ext cx="10698480" cy="566928"/>
+          </a:xfrm>
+          <a:prstGeom prst="rect">
+            <a:avLst/>
+          </a:prstGeom>
+          <a:noFill/>
+          <a:ln/>
+        </p:spPr>
+        <p:txBody>
+          <a:bodyPr wrap="square" lIns="0" tIns="0" rIns="0" bIns="0" rtlCol="0" anchor="t"/>
+          <a:lstStyle/>
+          <a:p>
+            <a:pPr indent="0" marL="0">
+              <a:lnSpc>
+                <a:spcPct val="105000"/>
+              </a:lnSpc>
+              <a:buNone/>
+            </a:pPr>
+            <a:r>
+              <a:rPr lang="en-US" sz="1200" b="1" dirty="0">
+                <a:solidFill>
+                  <a:srgbClr val="FFFFFF"/>
+                </a:solidFill>
+                <a:latin typeface="Calibri" pitchFamily="34" charset="0"/>
+                <a:ea typeface="Calibri" pitchFamily="34" charset="-122"/>
+                <a:cs typeface="Calibri" pitchFamily="34" charset="-120"/>
+              </a:rPr>
+              <a:t>[TEAM NAME - FILL IN]</a:t>
+            </a:r>
+            <a:endParaRPr lang="en-US" sz="1200" dirty="0"/>
+          </a:p>
+          <a:p>
+            <a:pPr indent="0" marL="0">
+              <a:lnSpc>
+                <a:spcPct val="105000"/>
+              </a:lnSpc>
+              <a:buNone/>
+            </a:pPr>
+            <a:r>
+              <a:rPr lang="en-US" sz="1200" dirty="0">
+                <a:solidFill>
+                  <a:srgbClr val="CADCFC"/>
+                </a:solidFill>
+                <a:latin typeface="Calibri" pitchFamily="34" charset="0"/>
+                <a:ea typeface="Calibri" pitchFamily="34" charset="-122"/>
+                <a:cs typeface="Calibri" pitchFamily="34" charset="-120"/>
+              </a:rPr>
+              <a:t>Junhong Zhou   ·   Tony Tran   ·   Faig Haji   ·   Bohan Zhang   ·   Alex [surname]</a:t>
+            </a:r>
+            <a:endParaRPr lang="en-US" sz="1200" dirty="0"/>
+          </a:p>
+        </p:txBody>
+      </p:sp>
     </p:spTree>
   </p:cSld>
   <p:clrMapOvr>

</xml_diff>

<commit_message>
Land the page 3 additions that a mis-indented patch had silently dropped
The previous commit claimed page 3 carried the fold split and the capital
convention. It did not: the patch searched for six spaces of indentation where
the file has four, so the replacement matched nothing and reported success.
Both are on the slide now, with the bullets condensed to five so the R2 table
below them is not pushed into the caption.

  "Trees won four of the six folds; Ridge joined the blend in 2022 and 2023"
  "Weights are fractions of NAV, summing to 200% gross and +12.5% net. Short
   proceeds sit in 3-month T-bills, which is why the benchmark is cash plus 4%
   and why the cash leg cancels out of the active return."

Verified this time by extracting the text back out of the rendered PDF rather
than trusting the edit, which is how the omission surfaced.

Co-Authored-By: Claude Opus 5 <noreply@anthropic.com>
</commit_message>
<xml_diff>
--- a/05_submission/FIAM_deck.pptx
+++ b/05_submission/FIAM_deck.pptx
@@ -17077,7 +17077,7 @@
         <p:spPr>
           <a:xfrm>
             <a:off x="548640" y="1700784"/>
-            <a:ext cx="5394960" cy="1463040"/>
+            <a:ext cx="5394960" cy="1828800"/>
           </a:xfrm>
           <a:prstGeom prst="rect">
             <a:avLst/>
@@ -17100,7 +17100,7 @@
               <a:buChar char="•"/>
             </a:pPr>
             <a:r>
-              <a:rPr lang="en-US" sz="1000" dirty="0">
+              <a:rPr lang="en-US" sz="950" dirty="0">
                 <a:solidFill>
                   <a:srgbClr val="1A1A1A"/>
                 </a:solidFill>
@@ -17108,9 +17108,9 @@
                 <a:ea typeface="Calibri" pitchFamily="34" charset="-122"/>
                 <a:cs typeface="Calibri" pitchFamily="34" charset="-120"/>
               </a:rPr>
-              <a:t>Gradient-boosted trees, refit annually on an expanding window with a rolling two-year validation block, split by target month. Chosen over the linear models on validation rank correlation, fold by fold.</a:t>
+              <a:t>Gradient-boosted trees, refit annually on an expanding window with a rolling two-year validation block, split by target month. Trees won four of the six folds; Ridge joined the blend in 2022 and 2023, on that fold's validation rank correlation.</a:t>
             </a:r>
-            <a:endParaRPr lang="en-US" sz="1000" dirty="0"/>
+            <a:endParaRPr lang="en-US" sz="950" dirty="0"/>
           </a:p>
           <a:p>
             <a:pPr marL="342900" indent="-342900">
@@ -17124,7 +17124,7 @@
               <a:buChar char="•"/>
             </a:pPr>
             <a:r>
-              <a:rPr lang="en-US" sz="1000" dirty="0">
+              <a:rPr lang="en-US" sz="950" dirty="0">
                 <a:solidFill>
                   <a:srgbClr val="1A1A1A"/>
                 </a:solidFill>
@@ -17134,7 +17134,7 @@
               </a:rPr>
               <a:t>Missing values are NOT imputed for the trees. Missingness is informative - stocks missing the most characteristics have a median cap of $282m against $1,687m.</a:t>
             </a:r>
-            <a:endParaRPr lang="en-US" sz="1000" dirty="0"/>
+            <a:endParaRPr lang="en-US" sz="950" dirty="0"/>
           </a:p>
           <a:p>
             <a:pPr marL="342900" indent="-342900">
@@ -17148,7 +17148,7 @@
               <a:buChar char="•"/>
             </a:pPr>
             <a:r>
-              <a:rPr lang="en-US" sz="1000" dirty="0">
+              <a:rPr lang="en-US" sz="950" dirty="0">
                 <a:solidFill>
                   <a:srgbClr val="1A1A1A"/>
                 </a:solidFill>
@@ -17158,7 +17158,7 @@
               </a:rPr>
               <a:t>The target is demeaned within each month. Fitting raw returns stopped after ONE boosting round: training averaged +0.27%/month against +2.52% in validation.</a:t>
             </a:r>
-            <a:endParaRPr lang="en-US" sz="1000" dirty="0"/>
+            <a:endParaRPr lang="en-US" sz="950" dirty="0"/>
           </a:p>
           <a:p>
             <a:pPr marL="342900" indent="-342900">
@@ -17172,7 +17172,7 @@
               <a:buChar char="•"/>
             </a:pPr>
             <a:r>
-              <a:rPr lang="en-US" sz="1000" dirty="0">
+              <a:rPr lang="en-US" sz="950" dirty="0">
                 <a:solidFill>
                   <a:srgbClr val="1A1A1A"/>
                 </a:solidFill>
@@ -17182,7 +17182,31 @@
               </a:rPr>
               <a:t>Model choice is made inside each fold on that fold's validation block only.</a:t>
             </a:r>
-            <a:endParaRPr lang="en-US" sz="1000" dirty="0"/>
+            <a:endParaRPr lang="en-US" sz="950" dirty="0"/>
+          </a:p>
+          <a:p>
+            <a:pPr marL="342900" indent="-342900">
+              <a:lnSpc>
+                <a:spcPct val="105000"/>
+              </a:lnSpc>
+              <a:spcAft>
+                <a:spcPts val="600"/>
+              </a:spcAft>
+              <a:buSzPct val="100000"/>
+              <a:buChar char="•"/>
+            </a:pPr>
+            <a:r>
+              <a:rPr lang="en-US" sz="950" dirty="0">
+                <a:solidFill>
+                  <a:srgbClr val="1A1A1A"/>
+                </a:solidFill>
+                <a:latin typeface="Calibri" pitchFamily="34" charset="0"/>
+                <a:ea typeface="Calibri" pitchFamily="34" charset="-122"/>
+                <a:cs typeface="Calibri" pitchFamily="34" charset="-120"/>
+              </a:rPr>
+              <a:t>Weights are fractions of NAV, summing to 200% gross and +12.5% net. Short proceeds sit in 3-month T-bills, which is why the benchmark is cash plus 4% and why the cash leg cancels out of the active return.</a:t>
+            </a:r>
+            <a:endParaRPr lang="en-US" sz="950" dirty="0"/>
           </a:p>
         </p:txBody>
       </p:sp>
@@ -17194,7 +17218,7 @@
         </p:nvSpPr>
         <p:spPr>
           <a:xfrm>
-            <a:off x="548640" y="3675888"/>
+            <a:off x="548640" y="3858768"/>
             <a:ext cx="5394960" cy="237744"/>
           </a:xfrm>
           <a:prstGeom prst="rect">
@@ -17240,7 +17264,7 @@
           </p:nvPr>
         </p:nvGraphicFramePr>
         <p:xfrm>
-          <a:off x="548640" y="3931920"/>
+          <a:off x="548640" y="4114800"/>
           <a:ext cx="5394960" cy="914400"/>
         </p:xfrm>
         <a:graphic>
@@ -18258,7 +18282,7 @@
         </p:nvSpPr>
         <p:spPr>
           <a:xfrm>
-            <a:off x="548640" y="5321808"/>
+            <a:off x="548640" y="5376672"/>
             <a:ext cx="5394960" cy="457200"/>
           </a:xfrm>
           <a:prstGeom prst="rect">
@@ -18283,7 +18307,7 @@
                 <a:ea typeface="Calibri" pitchFamily="34" charset="-122"/>
                 <a:cs typeface="Calibri" pitchFamily="34" charset="-120"/>
               </a:rPr>
-              <a:t>The rules note 1-2% is typical even for neural networks; a large positive number would mean a leak, not skill. The 8-K corpus was measured and excluded - three independent tests, one null, one exception, in the appendix.</a:t>
+              <a:t>The rules note 1-2% is typical even for neural networks; a large positive number would mean a leak, not skill. The 8-K corpus was measured and excluded - the appendix has all three tests.</a:t>
             </a:r>
             <a:endParaRPr lang="en-US" sz="1000" dirty="0"/>
           </a:p>
@@ -21674,12 +21698,12 @@
         </p:nvSpPr>
         <p:spPr>
           <a:xfrm>
-            <a:off x="548640" y="5797296"/>
-            <a:ext cx="11064240" cy="914400"/>
+            <a:off x="548640" y="5888736"/>
+            <a:ext cx="11064240" cy="859536"/>
           </a:xfrm>
           <a:prstGeom prst="roundRect">
             <a:avLst>
-              <a:gd name="adj" fmla="val 5000"/>
+              <a:gd name="adj" fmla="val 5319"/>
             </a:avLst>
           </a:prstGeom>
           <a:solidFill>
@@ -21701,8 +21725,8 @@
         </p:nvSpPr>
         <p:spPr>
           <a:xfrm>
-            <a:off x="749808" y="5888736"/>
-            <a:ext cx="10661904" cy="768096"/>
+            <a:off x="749808" y="5971032"/>
+            <a:ext cx="10661904" cy="731520"/>
           </a:xfrm>
           <a:prstGeom prst="rect">
             <a:avLst/>

</xml_diff>